<commit_message>
feat: neutralize branding to Global Card Payments Network, add interactive decision slider, live counter easing, anomaly search, and Render blueprint
</commit_message>
<xml_diff>
--- a/deliverables/SpendSense_Recommendations.pptx
+++ b/deliverables/SpendSense_Recommendations.pptx
@@ -3131,7 +3131,7 @@
               </a:defRPr>
             </a:pPr>
             <a:r>
-              <a:t>AMERICAN EXPRESS · CLOSED-LOOP PAYMENTS SIMULATION</a:t>
+              <a:t>GLOBAL CARD PAYMENTS NETWORK · RISK &amp; PORTFOLIO INTELLIGENCE</a:t>
             </a:r>
           </a:p>
           <a:p>
@@ -3437,7 +3437,7 @@
               </a:defRPr>
             </a:pPr>
             <a:r>
-              <a:t>03. Closed-Loop Pillars</a:t>
+              <a:t>03. Unified Pillars</a:t>
             </a:r>
           </a:p>
           <a:p>
@@ -3450,7 +3450,7 @@
               </a:defRPr>
             </a:pPr>
             <a:r>
-              <a:t>Dual analytical pillars matching Amex intern job descriptions: Risk Modeling (Logistic Regression baseline to XGBoost) and Customer Lifetime Value (RFM segmentation, Cohort analysis, and Profitability index).</a:t>
+              <a:t>Dual analytical pillars matching tier-1 card scheme analytics: Risk Modeling (Logistic Regression baseline to XGBoost) and Customer Lifetime Value (RFM segmentation, Cohort analysis, and Profitability index).</a:t>
             </a:r>
           </a:p>
         </p:txBody>

</xml_diff>